<commit_message>
Update deck with completed NSL drift evidence
</commit_message>
<xml_diff>
--- a/presentations/2026-10-10/NCD_Evidence_Update_2026-10-10.pptx
+++ b/presentations/2026-10-10/NCD_Evidence_Update_2026-10-10.pptx
@@ -14,9 +14,10 @@
     <p:sldId id="262" r:id="rId8"/>
     <p:sldId id="263" r:id="rId9"/>
     <p:sldId id="264" r:id="rId10"/>
+    <p:sldId id="265" r:id="rId11"/>
   </p:sldIdLst>
   <p:notesMasterIdLst>
-    <p:notesMasterId r:id="rId11"/>
+    <p:notesMasterId r:id="rId12"/>
   </p:notesMasterIdLst>
   <p:sldSz cx="12192000" cy="6858000"/>
   <p:notesSz cx="6858000" cy="12192000"/>
@@ -552,6 +553,94 @@
 </p:notes>
 </file>
 
+<file path=ppt/notesSlides/notesSlide10.xml><?xml version="1.0" encoding="utf-8"?>
+<p:notes xmlns:a="http://schemas.openxmlformats.org/drawingml/2006/main" xmlns:r="http://schemas.openxmlformats.org/officeDocument/2006/relationships" xmlns:p="http://schemas.openxmlformats.org/presentationml/2006/main">
+  <p:cSld>
+    <p:spTree>
+      <p:nvGrpSpPr>
+        <p:cNvPr id="1" name=""/>
+        <p:cNvGrpSpPr/>
+        <p:nvPr/>
+      </p:nvGrpSpPr>
+      <p:grpSpPr>
+        <a:xfrm>
+          <a:off x="0" y="0"/>
+          <a:ext cx="0" cy="0"/>
+          <a:chOff x="0" y="0"/>
+          <a:chExt cx="0" cy="0"/>
+        </a:xfrm>
+      </p:grpSpPr>
+      <p:sp>
+        <p:nvSpPr>
+          <p:cNvPr id="2" name="Slide Image Placeholder 1"/>
+          <p:cNvSpPr>
+            <a:spLocks noGrp="1" noRot="1" noChangeAspect="1"/>
+          </p:cNvSpPr>
+          <p:nvPr>
+            <p:ph type="sldImg"/>
+          </p:nvPr>
+        </p:nvSpPr>
+        <p:spPr/>
+      </p:sp>
+      <p:sp>
+        <p:nvSpPr>
+          <p:cNvPr id="3" name="Notes Placeholder 2"/>
+          <p:cNvSpPr>
+            <a:spLocks noGrp="1"/>
+          </p:cNvSpPr>
+          <p:nvPr>
+            <p:ph type="body" idx="1"/>
+          </p:nvPr>
+        </p:nvSpPr>
+        <p:spPr/>
+        <p:txBody>
+          <a:bodyPr/>
+          <a:lstStyle/>
+          <a:p>
+            <a:r>
+              <a:rPr lang="en-US" dirty="0"/>
+              <a:t/>
+            </a:r>
+            <a:endParaRPr lang="en-US" dirty="0"/>
+          </a:p>
+        </p:txBody>
+      </p:sp>
+      <p:sp>
+        <p:nvSpPr>
+          <p:cNvPr id="4" name="Slide Number Placeholder 3"/>
+          <p:cNvSpPr>
+            <a:spLocks noGrp="1"/>
+          </p:cNvSpPr>
+          <p:nvPr>
+            <p:ph type="sldNum" sz="quarter" idx="10"/>
+          </p:nvPr>
+        </p:nvSpPr>
+        <p:spPr/>
+        <p:txBody>
+          <a:bodyPr/>
+          <a:lstStyle/>
+          <a:p>
+            <a:fld id="{F7021451-1387-4CA6-816F-3879F97B5CBC}" type="slidenum">
+              <a:rPr lang="en-US"/>
+              <a:t>10</a:t>
+            </a:fld>
+            <a:endParaRPr lang="en-US"/>
+          </a:p>
+        </p:txBody>
+      </p:sp>
+    </p:spTree>
+    <p:extLst>
+      <p:ext uri="{BB962C8B-B14F-4D97-AF65-F5344CB8AC3E}">
+        <p14:creationId xmlns:p14="http://schemas.microsoft.com/office/powerpoint/2010/main" val="1024086991"/>
+      </p:ext>
+    </p:extLst>
+  </p:cSld>
+  <p:clrMapOvr>
+    <a:masterClrMapping/>
+  </p:clrMapOvr>
+</p:notes>
+</file>
+
 <file path=ppt/notesSlides/notesSlide2.xml><?xml version="1.0" encoding="utf-8"?>
 <p:notes xmlns:a="http://schemas.openxmlformats.org/drawingml/2006/main" xmlns:r="http://schemas.openxmlformats.org/officeDocument/2006/relationships" xmlns:p="http://schemas.openxmlformats.org/presentationml/2006/main">
   <p:cSld>
@@ -2139,6 +2228,817 @@
 </p:sld>
 </file>
 
+<file path=ppt/slides/slide10.xml><?xml version="1.0" encoding="utf-8"?>
+<p:sld xmlns:a="http://schemas.openxmlformats.org/drawingml/2006/main" xmlns:r="http://schemas.openxmlformats.org/officeDocument/2006/relationships" xmlns:p="http://schemas.openxmlformats.org/presentationml/2006/main">
+  <p:cSld name="Slide 10">
+    <p:bg>
+      <p:bgPr>
+        <a:solidFill>
+          <a:srgbClr val="0B1F33"/>
+        </a:solidFill>
+      </p:bgPr>
+    </p:bg>
+    <p:spTree>
+      <p:nvGrpSpPr>
+        <p:cNvPr id="1" name=""/>
+        <p:cNvGrpSpPr/>
+        <p:nvPr/>
+      </p:nvGrpSpPr>
+      <p:grpSpPr>
+        <a:xfrm>
+          <a:off x="0" y="0"/>
+          <a:ext cx="0" cy="0"/>
+          <a:chOff x="0" y="0"/>
+          <a:chExt cx="0" cy="0"/>
+        </a:xfrm>
+      </p:grpSpPr>
+      <p:sp>
+        <p:nvSpPr>
+          <p:cNvPr id="2" name="Shape 0"/>
+          <p:cNvSpPr/>
+          <p:nvPr/>
+        </p:nvSpPr>
+        <p:spPr>
+          <a:xfrm>
+            <a:off x="658368" y="457200"/>
+            <a:ext cx="2377440" cy="310896"/>
+          </a:xfrm>
+          <a:prstGeom prst="roundRect">
+            <a:avLst>
+              <a:gd name="adj" fmla="val 23529"/>
+            </a:avLst>
+          </a:prstGeom>
+          <a:solidFill>
+            <a:srgbClr val="0C7C86"/>
+          </a:solidFill>
+          <a:ln w="12700">
+            <a:solidFill>
+              <a:srgbClr val="0C7C86"/>
+            </a:solidFill>
+            <a:prstDash val="solid"/>
+          </a:ln>
+        </p:spPr>
+      </p:sp>
+      <p:sp>
+        <p:nvSpPr>
+          <p:cNvPr id="3" name="Text 1"/>
+          <p:cNvSpPr/>
+          <p:nvPr/>
+        </p:nvSpPr>
+        <p:spPr>
+          <a:xfrm>
+            <a:off x="731520" y="457200"/>
+            <a:ext cx="2231136" cy="310896"/>
+          </a:xfrm>
+          <a:prstGeom prst="rect">
+            <a:avLst/>
+          </a:prstGeom>
+          <a:noFill/>
+          <a:ln/>
+        </p:spPr>
+        <p:txBody>
+          <a:bodyPr wrap="square" lIns="0" tIns="0" rIns="0" bIns="0" rtlCol="0" anchor="ctr"/>
+          <a:lstStyle/>
+          <a:p>
+            <a:pPr algn="ctr" indent="0" marL="0">
+              <a:buNone/>
+            </a:pPr>
+            <a:r>
+              <a:rPr lang="en-US" sz="1000" b="1" dirty="0">
+                <a:solidFill>
+                  <a:srgbClr val="FFFFFF"/>
+                </a:solidFill>
+                <a:latin typeface="Arial" pitchFamily="34" charset="0"/>
+                <a:ea typeface="Arial" pitchFamily="34" charset="-122"/>
+                <a:cs typeface="Arial" pitchFamily="34" charset="-120"/>
+              </a:rPr>
+              <a:t>CURRENT EVIDENCE VERDICT</a:t>
+            </a:r>
+            <a:endParaRPr lang="en-US" sz="1000" dirty="0"/>
+          </a:p>
+        </p:txBody>
+      </p:sp>
+      <p:sp>
+        <p:nvSpPr>
+          <p:cNvPr id="4" name="Text 2"/>
+          <p:cNvSpPr/>
+          <p:nvPr/>
+        </p:nvSpPr>
+        <p:spPr>
+          <a:xfrm>
+            <a:off x="713232" y="1078992"/>
+            <a:ext cx="6720840" cy="1170432"/>
+          </a:xfrm>
+          <a:prstGeom prst="rect">
+            <a:avLst/>
+          </a:prstGeom>
+          <a:noFill/>
+          <a:ln/>
+        </p:spPr>
+        <p:txBody>
+          <a:bodyPr wrap="square" lIns="0" tIns="0" rIns="0" bIns="0" rtlCol="0" anchor="t"/>
+          <a:lstStyle/>
+          <a:p>
+            <a:pPr algn="l" indent="0" marL="0">
+              <a:buNone/>
+            </a:pPr>
+            <a:r>
+              <a:rPr lang="en-US" sz="3600" b="1" dirty="0">
+                <a:solidFill>
+                  <a:srgbClr val="FFFFFF"/>
+                </a:solidFill>
+                <a:latin typeface="Cambria" pitchFamily="34" charset="0"/>
+                <a:ea typeface="Cambria" pitchFamily="34" charset="-122"/>
+                <a:cs typeface="Cambria" pitchFamily="34" charset="-120"/>
+              </a:rPr>
+              <a:t>The measurement works.</a:t>
+            </a:r>
+            <a:endParaRPr lang="en-US" sz="3600" dirty="0"/>
+          </a:p>
+          <a:p>
+            <a:pPr algn="l" indent="0" marL="0">
+              <a:buNone/>
+            </a:pPr>
+            <a:r>
+              <a:rPr lang="en-US" sz="3600" b="1" dirty="0">
+                <a:solidFill>
+                  <a:srgbClr val="FFFFFF"/>
+                </a:solidFill>
+                <a:latin typeface="Cambria" pitchFamily="34" charset="0"/>
+                <a:ea typeface="Cambria" pitchFamily="34" charset="-122"/>
+                <a:cs typeface="Cambria" pitchFamily="34" charset="-120"/>
+              </a:rPr>
+              <a:t>The innovation claim does not—yet.</a:t>
+            </a:r>
+            <a:endParaRPr lang="en-US" sz="3600" dirty="0"/>
+          </a:p>
+        </p:txBody>
+      </p:sp>
+      <p:sp>
+        <p:nvSpPr>
+          <p:cNvPr id="5" name="Shape 3"/>
+          <p:cNvSpPr/>
+          <p:nvPr/>
+        </p:nvSpPr>
+        <p:spPr>
+          <a:xfrm>
+            <a:off x="749808" y="2670048"/>
+            <a:ext cx="1170432" cy="310896"/>
+          </a:xfrm>
+          <a:prstGeom prst="roundRect">
+            <a:avLst>
+              <a:gd name="adj" fmla="val 23529"/>
+            </a:avLst>
+          </a:prstGeom>
+          <a:solidFill>
+            <a:srgbClr val="356B4D"/>
+          </a:solidFill>
+          <a:ln w="12700">
+            <a:solidFill>
+              <a:srgbClr val="356B4D"/>
+            </a:solidFill>
+            <a:prstDash val="solid"/>
+          </a:ln>
+        </p:spPr>
+      </p:sp>
+      <p:sp>
+        <p:nvSpPr>
+          <p:cNvPr id="6" name="Text 4"/>
+          <p:cNvSpPr/>
+          <p:nvPr/>
+        </p:nvSpPr>
+        <p:spPr>
+          <a:xfrm>
+            <a:off x="822960" y="2670048"/>
+            <a:ext cx="1024128" cy="310896"/>
+          </a:xfrm>
+          <a:prstGeom prst="rect">
+            <a:avLst/>
+          </a:prstGeom>
+          <a:noFill/>
+          <a:ln/>
+        </p:spPr>
+        <p:txBody>
+          <a:bodyPr wrap="square" lIns="0" tIns="0" rIns="0" bIns="0" rtlCol="0" anchor="ctr"/>
+          <a:lstStyle/>
+          <a:p>
+            <a:pPr algn="ctr" indent="0" marL="0">
+              <a:buNone/>
+            </a:pPr>
+            <a:r>
+              <a:rPr lang="en-US" sz="1000" b="1" dirty="0">
+                <a:solidFill>
+                  <a:srgbClr val="FFFFFF"/>
+                </a:solidFill>
+                <a:latin typeface="Arial" pitchFamily="34" charset="0"/>
+                <a:ea typeface="Arial" pitchFamily="34" charset="-122"/>
+                <a:cs typeface="Arial" pitchFamily="34" charset="-120"/>
+              </a:rPr>
+              <a:t>SUPPORTED</a:t>
+            </a:r>
+            <a:endParaRPr lang="en-US" sz="1000" dirty="0"/>
+          </a:p>
+        </p:txBody>
+      </p:sp>
+      <p:sp>
+        <p:nvSpPr>
+          <p:cNvPr id="7" name="Text 5"/>
+          <p:cNvSpPr/>
+          <p:nvPr/>
+        </p:nvSpPr>
+        <p:spPr>
+          <a:xfrm>
+            <a:off x="2121408" y="2642616"/>
+            <a:ext cx="6035040" cy="420624"/>
+          </a:xfrm>
+          <a:prstGeom prst="rect">
+            <a:avLst/>
+          </a:prstGeom>
+          <a:noFill/>
+          <a:ln/>
+        </p:spPr>
+        <p:txBody>
+          <a:bodyPr wrap="square" lIns="0" tIns="0" rIns="0" bIns="0" rtlCol="0" anchor="ctr"/>
+          <a:lstStyle/>
+          <a:p>
+            <a:pPr algn="l" indent="0" marL="0">
+              <a:buNone/>
+            </a:pPr>
+            <a:r>
+              <a:rPr lang="en-US" sz="1500" dirty="0">
+                <a:solidFill>
+                  <a:srgbClr val="FFFFFF"/>
+                </a:solidFill>
+                <a:latin typeface="Arial" pitchFamily="34" charset="0"/>
+                <a:ea typeface="Arial" pitchFamily="34" charset="-122"/>
+                <a:cs typeface="Arial" pitchFamily="34" charset="-120"/>
+              </a:rPr>
+              <a:t>Repeated explanations and intervention constructions are auditable.</a:t>
+            </a:r>
+            <a:endParaRPr lang="en-US" sz="1500" dirty="0"/>
+          </a:p>
+        </p:txBody>
+      </p:sp>
+      <p:sp>
+        <p:nvSpPr>
+          <p:cNvPr id="8" name="Shape 6"/>
+          <p:cNvSpPr/>
+          <p:nvPr/>
+        </p:nvSpPr>
+        <p:spPr>
+          <a:xfrm>
+            <a:off x="749808" y="3611880"/>
+            <a:ext cx="1170432" cy="310896"/>
+          </a:xfrm>
+          <a:prstGeom prst="roundRect">
+            <a:avLst>
+              <a:gd name="adj" fmla="val 23529"/>
+            </a:avLst>
+          </a:prstGeom>
+          <a:solidFill>
+            <a:srgbClr val="7C3F68"/>
+          </a:solidFill>
+          <a:ln w="12700">
+            <a:solidFill>
+              <a:srgbClr val="7C3F68"/>
+            </a:solidFill>
+            <a:prstDash val="solid"/>
+          </a:ln>
+        </p:spPr>
+      </p:sp>
+      <p:sp>
+        <p:nvSpPr>
+          <p:cNvPr id="9" name="Text 7"/>
+          <p:cNvSpPr/>
+          <p:nvPr/>
+        </p:nvSpPr>
+        <p:spPr>
+          <a:xfrm>
+            <a:off x="822960" y="3611880"/>
+            <a:ext cx="1024128" cy="310896"/>
+          </a:xfrm>
+          <a:prstGeom prst="rect">
+            <a:avLst/>
+          </a:prstGeom>
+          <a:noFill/>
+          <a:ln/>
+        </p:spPr>
+        <p:txBody>
+          <a:bodyPr wrap="square" lIns="0" tIns="0" rIns="0" bIns="0" rtlCol="0" anchor="ctr"/>
+          <a:lstStyle/>
+          <a:p>
+            <a:pPr algn="ctr" indent="0" marL="0">
+              <a:buNone/>
+            </a:pPr>
+            <a:r>
+              <a:rPr lang="en-US" sz="1000" b="1" dirty="0">
+                <a:solidFill>
+                  <a:srgbClr val="FFFFFF"/>
+                </a:solidFill>
+                <a:latin typeface="Arial" pitchFamily="34" charset="0"/>
+                <a:ea typeface="Arial" pitchFamily="34" charset="-122"/>
+                <a:cs typeface="Arial" pitchFamily="34" charset="-120"/>
+              </a:rPr>
+              <a:t>NEGATIVE</a:t>
+            </a:r>
+            <a:endParaRPr lang="en-US" sz="1000" dirty="0"/>
+          </a:p>
+        </p:txBody>
+      </p:sp>
+      <p:sp>
+        <p:nvSpPr>
+          <p:cNvPr id="10" name="Text 8"/>
+          <p:cNvSpPr/>
+          <p:nvPr/>
+        </p:nvSpPr>
+        <p:spPr>
+          <a:xfrm>
+            <a:off x="2121408" y="3584448"/>
+            <a:ext cx="6035040" cy="420624"/>
+          </a:xfrm>
+          <a:prstGeom prst="rect">
+            <a:avLst/>
+          </a:prstGeom>
+          <a:noFill/>
+          <a:ln/>
+        </p:spPr>
+        <p:txBody>
+          <a:bodyPr wrap="square" lIns="0" tIns="0" rIns="0" bIns="0" rtlCol="0" anchor="ctr"/>
+          <a:lstStyle/>
+          <a:p>
+            <a:pPr algn="l" indent="0" marL="0">
+              <a:buNone/>
+            </a:pPr>
+            <a:r>
+              <a:rPr lang="en-US" sz="1500" dirty="0">
+                <a:solidFill>
+                  <a:srgbClr val="FFFFFF"/>
+                </a:solidFill>
+                <a:latin typeface="Arial" pitchFamily="34" charset="0"/>
+                <a:ea typeface="Arial" pitchFamily="34" charset="-122"/>
+                <a:cs typeface="Arial" pitchFamily="34" charset="-120"/>
+              </a:rPr>
+              <a:t>NCD ties B2 on eligible positives, adds one false positive, and marks 154/157 silent units in the completed NSL drift slice.</a:t>
+            </a:r>
+            <a:endParaRPr lang="en-US" sz="1500" dirty="0"/>
+          </a:p>
+        </p:txBody>
+      </p:sp>
+      <p:sp>
+        <p:nvSpPr>
+          <p:cNvPr id="11" name="Shape 9"/>
+          <p:cNvSpPr/>
+          <p:nvPr/>
+        </p:nvSpPr>
+        <p:spPr>
+          <a:xfrm>
+            <a:off x="749808" y="4553712"/>
+            <a:ext cx="1170432" cy="310896"/>
+          </a:xfrm>
+          <a:prstGeom prst="roundRect">
+            <a:avLst>
+              <a:gd name="adj" fmla="val 23529"/>
+            </a:avLst>
+          </a:prstGeom>
+          <a:solidFill>
+            <a:srgbClr val="B47B18"/>
+          </a:solidFill>
+          <a:ln w="12700">
+            <a:solidFill>
+              <a:srgbClr val="B47B18"/>
+            </a:solidFill>
+            <a:prstDash val="solid"/>
+          </a:ln>
+        </p:spPr>
+      </p:sp>
+      <p:sp>
+        <p:nvSpPr>
+          <p:cNvPr id="12" name="Text 10"/>
+          <p:cNvSpPr/>
+          <p:nvPr/>
+        </p:nvSpPr>
+        <p:spPr>
+          <a:xfrm>
+            <a:off x="822960" y="4553712"/>
+            <a:ext cx="1024128" cy="310896"/>
+          </a:xfrm>
+          <a:prstGeom prst="rect">
+            <a:avLst/>
+          </a:prstGeom>
+          <a:noFill/>
+          <a:ln/>
+        </p:spPr>
+        <p:txBody>
+          <a:bodyPr wrap="square" lIns="0" tIns="0" rIns="0" bIns="0" rtlCol="0" anchor="ctr"/>
+          <a:lstStyle/>
+          <a:p>
+            <a:pPr algn="ctr" indent="0" marL="0">
+              <a:buNone/>
+            </a:pPr>
+            <a:r>
+              <a:rPr lang="en-US" sz="1000" b="1" dirty="0">
+                <a:solidFill>
+                  <a:srgbClr val="FFFFFF"/>
+                </a:solidFill>
+                <a:latin typeface="Arial" pitchFamily="34" charset="0"/>
+                <a:ea typeface="Arial" pitchFamily="34" charset="-122"/>
+                <a:cs typeface="Arial" pitchFamily="34" charset="-120"/>
+              </a:rPr>
+              <a:t>OPEN</a:t>
+            </a:r>
+            <a:endParaRPr lang="en-US" sz="1000" dirty="0"/>
+          </a:p>
+        </p:txBody>
+      </p:sp>
+      <p:sp>
+        <p:nvSpPr>
+          <p:cNvPr id="13" name="Text 11"/>
+          <p:cNvSpPr/>
+          <p:nvPr/>
+        </p:nvSpPr>
+        <p:spPr>
+          <a:xfrm>
+            <a:off x="2121408" y="4526280"/>
+            <a:ext cx="6035040" cy="420624"/>
+          </a:xfrm>
+          <a:prstGeom prst="rect">
+            <a:avLst/>
+          </a:prstGeom>
+          <a:noFill/>
+          <a:ln/>
+        </p:spPr>
+        <p:txBody>
+          <a:bodyPr wrap="square" lIns="0" tIns="0" rIns="0" bIns="0" rtlCol="0" anchor="ctr"/>
+          <a:lstStyle/>
+          <a:p>
+            <a:pPr algn="l" indent="0" marL="0">
+              <a:buNone/>
+            </a:pPr>
+            <a:r>
+              <a:rPr lang="en-US" sz="1500" dirty="0">
+                <a:solidFill>
+                  <a:srgbClr val="FFFFFF"/>
+                </a:solidFill>
+                <a:latin typeface="Arial" pitchFamily="34" charset="0"/>
+                <a:ea typeface="Arial" pitchFamily="34" charset="-122"/>
+                <a:cs typeface="Arial" pitchFamily="34" charset="-120"/>
+              </a:rPr>
+              <a:t>Matched NSL performance, the other three datasets, cross-explainer validity, future-recall relation, and RQ3 governance.</a:t>
+            </a:r>
+            <a:endParaRPr lang="en-US" sz="1500" dirty="0"/>
+          </a:p>
+        </p:txBody>
+      </p:sp>
+      <p:sp>
+        <p:nvSpPr>
+          <p:cNvPr id="14" name="Shape 12"/>
+          <p:cNvSpPr/>
+          <p:nvPr/>
+        </p:nvSpPr>
+        <p:spPr>
+          <a:xfrm>
+            <a:off x="8412480" y="1078992"/>
+            <a:ext cx="2926080" cy="4535424"/>
+          </a:xfrm>
+          <a:prstGeom prst="roundRect">
+            <a:avLst>
+              <a:gd name="adj" fmla="val 2500"/>
+            </a:avLst>
+          </a:prstGeom>
+          <a:solidFill>
+            <a:srgbClr val="132D45"/>
+          </a:solidFill>
+          <a:ln w="12700">
+            <a:solidFill>
+              <a:srgbClr val="26445D"/>
+            </a:solidFill>
+            <a:prstDash val="solid"/>
+          </a:ln>
+        </p:spPr>
+      </p:sp>
+      <p:sp>
+        <p:nvSpPr>
+          <p:cNvPr id="15" name="Text 13"/>
+          <p:cNvSpPr/>
+          <p:nvPr/>
+        </p:nvSpPr>
+        <p:spPr>
+          <a:xfrm>
+            <a:off x="8705088" y="1417320"/>
+            <a:ext cx="2331720" cy="402336"/>
+          </a:xfrm>
+          <a:prstGeom prst="rect">
+            <a:avLst/>
+          </a:prstGeom>
+          <a:noFill/>
+          <a:ln/>
+        </p:spPr>
+        <p:txBody>
+          <a:bodyPr wrap="square" lIns="0" tIns="0" rIns="0" bIns="0" rtlCol="0" anchor="ctr"/>
+          <a:lstStyle/>
+          <a:p>
+            <a:pPr algn="ctr" indent="0" marL="0">
+              <a:buNone/>
+            </a:pPr>
+            <a:r>
+              <a:rPr lang="en-US" sz="2100" b="1" dirty="0">
+                <a:solidFill>
+                  <a:srgbClr val="FFFFFF"/>
+                </a:solidFill>
+                <a:latin typeface="Cambria" pitchFamily="34" charset="0"/>
+                <a:ea typeface="Cambria" pitchFamily="34" charset="-122"/>
+                <a:cs typeface="Cambria" pitchFamily="34" charset="-120"/>
+              </a:rPr>
+              <a:t>HPC completion path</a:t>
+            </a:r>
+            <a:endParaRPr lang="en-US" sz="2100" dirty="0"/>
+          </a:p>
+        </p:txBody>
+      </p:sp>
+      <p:sp>
+        <p:nvSpPr>
+          <p:cNvPr id="16" name="Text 14"/>
+          <p:cNvSpPr/>
+          <p:nvPr/>
+        </p:nvSpPr>
+        <p:spPr>
+          <a:xfrm>
+            <a:off x="8723376" y="2029968"/>
+            <a:ext cx="2286000" cy="3090672"/>
+          </a:xfrm>
+          <a:prstGeom prst="rect">
+            <a:avLst/>
+          </a:prstGeom>
+          <a:noFill/>
+          <a:ln/>
+        </p:spPr>
+        <p:txBody>
+          <a:bodyPr wrap="square" lIns="0" tIns="0" rIns="0" bIns="0" rtlCol="0" anchor="t"/>
+          <a:lstStyle/>
+          <a:p>
+            <a:pPr algn="ctr" indent="0" marL="0">
+              <a:buNone/>
+            </a:pPr>
+            <a:r>
+              <a:rPr lang="en-US" sz="1400" dirty="0">
+                <a:solidFill>
+                  <a:srgbClr val="D7E2EB"/>
+                </a:solidFill>
+                <a:latin typeface="Arial" pitchFamily="34" charset="0"/>
+                <a:ea typeface="Arial" pitchFamily="34" charset="-122"/>
+                <a:cs typeface="Arial" pitchFamily="34" charset="-120"/>
+              </a:rPr>
+              <a:t>12 registered owned jobs</a:t>
+            </a:r>
+            <a:endParaRPr lang="en-US" sz="1400" dirty="0"/>
+          </a:p>
+          <a:p>
+            <a:pPr algn="ctr" indent="0" marL="0">
+              <a:buNone/>
+            </a:pPr>
+            <a:endParaRPr lang="en-US" sz="1400" dirty="0"/>
+          </a:p>
+          <a:p>
+            <a:pPr algn="ctr" indent="0" marL="0">
+              <a:buNone/>
+            </a:pPr>
+            <a:r>
+              <a:rPr lang="en-US" sz="1400" dirty="0">
+                <a:solidFill>
+                  <a:srgbClr val="D7E2EB"/>
+                </a:solidFill>
+                <a:latin typeface="Arial" pitchFamily="34" charset="0"/>
+                <a:ea typeface="Arial" pitchFamily="34" charset="-122"/>
+                <a:cs typeface="Arial" pitchFamily="34" charset="-120"/>
+              </a:rPr>
+              <a:t>2 complete</a:t>
+            </a:r>
+            <a:endParaRPr lang="en-US" sz="1400" dirty="0"/>
+          </a:p>
+          <a:p>
+            <a:pPr algn="ctr" indent="0" marL="0">
+              <a:buNone/>
+            </a:pPr>
+            <a:r>
+              <a:rPr lang="en-US" sz="1400" dirty="0">
+                <a:solidFill>
+                  <a:srgbClr val="D7E2EB"/>
+                </a:solidFill>
+                <a:latin typeface="Arial" pitchFamily="34" charset="0"/>
+                <a:ea typeface="Arial" pitchFamily="34" charset="-122"/>
+                <a:cs typeface="Arial" pitchFamily="34" charset="-120"/>
+              </a:rPr>
+              <a:t>10 queued or dependency-held</a:t>
+            </a:r>
+            <a:endParaRPr lang="en-US" sz="1400" dirty="0"/>
+          </a:p>
+          <a:p>
+            <a:pPr algn="ctr" indent="0" marL="0">
+              <a:buNone/>
+            </a:pPr>
+            <a:endParaRPr lang="en-US" sz="1400" dirty="0"/>
+          </a:p>
+          <a:p>
+            <a:pPr algn="ctr" indent="0" marL="0">
+              <a:buNone/>
+            </a:pPr>
+            <a:r>
+              <a:rPr lang="en-US" sz="1400" dirty="0">
+                <a:solidFill>
+                  <a:srgbClr val="D7E2EB"/>
+                </a:solidFill>
+                <a:latin typeface="Arial" pitchFamily="34" charset="0"/>
+                <a:ea typeface="Arial" pitchFamily="34" charset="-122"/>
+                <a:cs typeface="Arial" pitchFamily="34" charset="-120"/>
+              </a:rPr>
+              <a:t>4 primary runs</a:t>
+            </a:r>
+            <a:endParaRPr lang="en-US" sz="1400" dirty="0"/>
+          </a:p>
+          <a:p>
+            <a:pPr algn="ctr" indent="0" marL="0">
+              <a:buNone/>
+            </a:pPr>
+            <a:r>
+              <a:rPr lang="en-US" sz="1400" dirty="0">
+                <a:solidFill>
+                  <a:srgbClr val="D7E2EB"/>
+                </a:solidFill>
+                <a:latin typeface="Arial" pitchFamily="34" charset="0"/>
+                <a:ea typeface="Arial" pitchFamily="34" charset="-122"/>
+                <a:cs typeface="Arial" pitchFamily="34" charset="-120"/>
+              </a:rPr>
+              <a:t>4 performance aggregations</a:t>
+            </a:r>
+            <a:endParaRPr lang="en-US" sz="1400" dirty="0"/>
+          </a:p>
+          <a:p>
+            <a:pPr algn="ctr" indent="0" marL="0">
+              <a:buNone/>
+            </a:pPr>
+            <a:r>
+              <a:rPr lang="en-US" sz="1400" dirty="0">
+                <a:solidFill>
+                  <a:srgbClr val="D7E2EB"/>
+                </a:solidFill>
+                <a:latin typeface="Arial" pitchFamily="34" charset="0"/>
+                <a:ea typeface="Arial" pitchFamily="34" charset="-122"/>
+                <a:cs typeface="Arial" pitchFamily="34" charset="-120"/>
+              </a:rPr>
+              <a:t>4 drift aggregations</a:t>
+            </a:r>
+            <a:endParaRPr lang="en-US" sz="1400" dirty="0"/>
+          </a:p>
+          <a:p>
+            <a:pPr algn="ctr" indent="0" marL="0">
+              <a:buNone/>
+            </a:pPr>
+            <a:endParaRPr lang="en-US" sz="1400" dirty="0"/>
+          </a:p>
+          <a:p>
+            <a:pPr algn="ctr" indent="0" marL="0">
+              <a:buNone/>
+            </a:pPr>
+            <a:r>
+              <a:rPr lang="en-US" sz="1400" dirty="0">
+                <a:solidFill>
+                  <a:srgbClr val="D7E2EB"/>
+                </a:solidFill>
+                <a:latin typeface="Arial" pitchFamily="34" charset="0"/>
+                <a:ea typeface="Arial" pitchFamily="34" charset="-122"/>
+                <a:cs typeface="Arial" pitchFamily="34" charset="-120"/>
+              </a:rPr>
+              <a:t>No duplicate submission.</a:t>
+            </a:r>
+            <a:endParaRPr lang="en-US" sz="1400" dirty="0"/>
+          </a:p>
+        </p:txBody>
+      </p:sp>
+      <p:sp>
+        <p:nvSpPr>
+          <p:cNvPr id="17" name="Text 15"/>
+          <p:cNvSpPr/>
+          <p:nvPr/>
+        </p:nvSpPr>
+        <p:spPr>
+          <a:xfrm>
+            <a:off x="749808" y="5852160"/>
+            <a:ext cx="10405872" cy="438912"/>
+          </a:xfrm>
+          <a:prstGeom prst="rect">
+            <a:avLst/>
+          </a:prstGeom>
+          <a:noFill/>
+          <a:ln/>
+        </p:spPr>
+        <p:txBody>
+          <a:bodyPr wrap="square" lIns="0" tIns="0" rIns="0" bIns="0" rtlCol="0" anchor="ctr"/>
+          <a:lstStyle/>
+          <a:p>
+            <a:pPr algn="l" indent="0" marL="0">
+              <a:buNone/>
+            </a:pPr>
+            <a:r>
+              <a:rPr lang="en-US" sz="1500" b="1" dirty="0">
+                <a:solidFill>
+                  <a:srgbClr val="F0C8DE"/>
+                </a:solidFill>
+                <a:latin typeface="Arial" pitchFamily="34" charset="0"/>
+                <a:ea typeface="Arial" pitchFamily="34" charset="-122"/>
+                <a:cs typeface="Arial" pitchFamily="34" charset="-120"/>
+              </a:rPr>
+              <a:t>No current result establishes substantive innovation, cross-domain generality, or validated governance.</a:t>
+            </a:r>
+            <a:endParaRPr lang="en-US" sz="1500" dirty="0"/>
+          </a:p>
+        </p:txBody>
+      </p:sp>
+      <p:sp>
+        <p:nvSpPr>
+          <p:cNvPr id="18" name="Text 16"/>
+          <p:cNvSpPr/>
+          <p:nvPr/>
+        </p:nvSpPr>
+        <p:spPr>
+          <a:xfrm>
+            <a:off x="594360" y="6565392"/>
+            <a:ext cx="10287000" cy="164592"/>
+          </a:xfrm>
+          <a:prstGeom prst="rect">
+            <a:avLst/>
+          </a:prstGeom>
+          <a:noFill/>
+          <a:ln/>
+        </p:spPr>
+        <p:txBody>
+          <a:bodyPr wrap="square" lIns="0" tIns="0" rIns="0" bIns="0" rtlCol="0" anchor="ctr"/>
+          <a:lstStyle/>
+          <a:p>
+            <a:pPr algn="l" indent="0" marL="0">
+              <a:buNone/>
+            </a:pPr>
+            <a:r>
+              <a:rPr lang="en-US" sz="850" dirty="0">
+                <a:solidFill>
+                  <a:srgbClr val="D5DEE7"/>
+                </a:solidFill>
+                <a:latin typeface="Arial" pitchFamily="34" charset="0"/>
+                <a:ea typeface="Arial" pitchFamily="34" charset="-122"/>
+                <a:cs typeface="Arial" pitchFamily="34" charset="-120"/>
+              </a:rPr>
+              <a:t>Next: audit matched NSL performance and each remaining terminal protected result before replacing interim tables</a:t>
+            </a:r>
+            <a:endParaRPr lang="en-US" sz="850" dirty="0"/>
+          </a:p>
+        </p:txBody>
+      </p:sp>
+      <p:sp>
+        <p:nvSpPr>
+          <p:cNvPr id="19" name="Text 17"/>
+          <p:cNvSpPr/>
+          <p:nvPr/>
+        </p:nvSpPr>
+        <p:spPr>
+          <a:xfrm>
+            <a:off x="11109960" y="6547104"/>
+            <a:ext cx="457200" cy="182880"/>
+          </a:xfrm>
+          <a:prstGeom prst="rect">
+            <a:avLst/>
+          </a:prstGeom>
+          <a:noFill/>
+          <a:ln/>
+        </p:spPr>
+        <p:txBody>
+          <a:bodyPr wrap="square" lIns="0" tIns="0" rIns="0" bIns="0" rtlCol="0" anchor="ctr"/>
+          <a:lstStyle/>
+          <a:p>
+            <a:pPr algn="r" indent="0" marL="0">
+              <a:buNone/>
+            </a:pPr>
+            <a:r>
+              <a:rPr lang="en-US" sz="900" dirty="0">
+                <a:solidFill>
+                  <a:srgbClr val="D5DEE7"/>
+                </a:solidFill>
+                <a:latin typeface="Arial" pitchFamily="34" charset="0"/>
+                <a:ea typeface="Arial" pitchFamily="34" charset="-122"/>
+                <a:cs typeface="Arial" pitchFamily="34" charset="-120"/>
+              </a:rPr>
+              <a:t>10</a:t>
+            </a:r>
+            <a:endParaRPr lang="en-US" sz="900" dirty="0"/>
+          </a:p>
+        </p:txBody>
+      </p:sp>
+    </p:spTree>
+  </p:cSld>
+  <p:clrMapOvr>
+    <a:masterClrMapping/>
+  </p:clrMapOvr>
+</p:sld>
+</file>
+
 <file path=ppt/slides/slide2.xml><?xml version="1.0" encoding="utf-8"?>
 <p:sld xmlns:a="http://schemas.openxmlformats.org/drawingml/2006/main" xmlns:r="http://schemas.openxmlformats.org/officeDocument/2006/relationships" xmlns:p="http://schemas.openxmlformats.org/presentationml/2006/main">
   <p:cSld name="Slide 2">
@@ -11342,7 +12242,7 @@
     <p:bg>
       <p:bgPr>
         <a:solidFill>
-          <a:srgbClr val="0B1F33"/>
+          <a:srgbClr val="FFFFFF"/>
         </a:solidFill>
       </p:bgPr>
     </p:bg>
@@ -11362,41 +12262,150 @@
       </p:grpSpPr>
       <p:sp>
         <p:nvSpPr>
-          <p:cNvPr id="2" name="Shape 0"/>
-          <p:cNvSpPr/>
-          <p:nvPr/>
-        </p:nvSpPr>
-        <p:spPr>
-          <a:xfrm>
-            <a:off x="658368" y="457200"/>
-            <a:ext cx="2377440" cy="310896"/>
+          <p:cNvPr id="2" name="Text 0"/>
+          <p:cNvSpPr/>
+          <p:nvPr/>
+        </p:nvSpPr>
+        <p:spPr>
+          <a:xfrm>
+            <a:off x="594360" y="347472"/>
+            <a:ext cx="10927080" cy="438912"/>
+          </a:xfrm>
+          <a:prstGeom prst="rect">
+            <a:avLst/>
+          </a:prstGeom>
+          <a:noFill/>
+          <a:ln/>
+        </p:spPr>
+        <p:txBody>
+          <a:bodyPr wrap="square" lIns="0" tIns="0" rIns="0" bIns="0" rtlCol="0" anchor="ctr"/>
+          <a:lstStyle/>
+          <a:p>
+            <a:pPr algn="l" indent="0" marL="0">
+              <a:buNone/>
+            </a:pPr>
+            <a:r>
+              <a:rPr lang="en-US" sz="3000" b="1" dirty="0">
+                <a:solidFill>
+                  <a:srgbClr val="0B1F33"/>
+                </a:solidFill>
+                <a:latin typeface="Cambria" pitchFamily="34" charset="0"/>
+                <a:ea typeface="Cambria" pitchFamily="34" charset="-122"/>
+                <a:cs typeface="Cambria" pitchFamily="34" charset="-120"/>
+              </a:rPr>
+              <a:t>NSL-KDD 25-run drift slice: saturation persists</a:t>
+            </a:r>
+            <a:endParaRPr lang="en-US" sz="3000" dirty="0"/>
+          </a:p>
+        </p:txBody>
+      </p:sp>
+      <p:sp>
+        <p:nvSpPr>
+          <p:cNvPr id="3" name="Text 1"/>
+          <p:cNvSpPr/>
+          <p:nvPr/>
+        </p:nvSpPr>
+        <p:spPr>
+          <a:xfrm>
+            <a:off x="612648" y="822960"/>
+            <a:ext cx="10789920" cy="274320"/>
+          </a:xfrm>
+          <a:prstGeom prst="rect">
+            <a:avLst/>
+          </a:prstGeom>
+          <a:noFill/>
+          <a:ln/>
+        </p:spPr>
+        <p:txBody>
+          <a:bodyPr wrap="square" lIns="0" tIns="0" rIns="0" bIns="0" rtlCol="0" anchor="ctr"/>
+          <a:lstStyle/>
+          <a:p>
+            <a:pPr algn="l" indent="0" marL="0">
+              <a:buNone/>
+            </a:pPr>
+            <a:r>
+              <a:rPr lang="en-US" sz="1150" dirty="0">
+                <a:solidFill>
+                  <a:srgbClr val="5F6E7C"/>
+                </a:solidFill>
+                <a:latin typeface="Arial" pitchFamily="34" charset="0"/>
+                <a:ea typeface="Arial" pitchFamily="34" charset="-122"/>
+                <a:cs typeface="Arial" pitchFamily="34" charset="-120"/>
+              </a:rPr>
+              <a:t>Five learners × five seeds; matched performance aggregation remains queued.</a:t>
+            </a:r>
+            <a:endParaRPr lang="en-US" sz="1150" dirty="0"/>
+          </a:p>
+        </p:txBody>
+      </p:sp>
+      <p:pic>
+        <p:nvPicPr>
+          <p:cNvPr id="4" name="Image 0" descr="C:\Users\PC\Documents\Codex\2026-07-10\he-l\work\github_private_current\paper_ncd\figures\nsl_25run_drift_saturation.png">    </p:cNvPr>
+          <p:cNvPicPr>
+            <a:picLocks noChangeAspect="1"/>
+          </p:cNvPicPr>
+          <p:nvPr/>
+        </p:nvPicPr>
+        <p:blipFill>
+          <a:blip r:embed="rId1"/>
+          <a:stretch>
+            <a:fillRect/>
+          </a:stretch>
+        </p:blipFill>
+        <p:spPr>
+          <a:xfrm>
+            <a:off x="438912" y="1170432"/>
+            <a:ext cx="7973568" cy="4407408"/>
+          </a:xfrm>
+          <a:prstGeom prst="rect">
+            <a:avLst/>
+          </a:prstGeom>
+        </p:spPr>
+      </p:pic>
+      <p:sp>
+        <p:nvSpPr>
+          <p:cNvPr id="5" name="Shape 2"/>
+          <p:cNvSpPr/>
+          <p:nvPr/>
+        </p:nvSpPr>
+        <p:spPr>
+          <a:xfrm>
+            <a:off x="8668512" y="1298448"/>
+            <a:ext cx="2779776" cy="4242816"/>
           </a:xfrm>
           <a:prstGeom prst="roundRect">
             <a:avLst>
-              <a:gd name="adj" fmla="val 23529"/>
+              <a:gd name="adj" fmla="val 2632"/>
             </a:avLst>
           </a:prstGeom>
           <a:solidFill>
-            <a:srgbClr val="0C7C86"/>
+            <a:srgbClr val="F6F8FA"/>
           </a:solidFill>
           <a:ln w="12700">
             <a:solidFill>
-              <a:srgbClr val="0C7C86"/>
+              <a:srgbClr val="CBD5DE"/>
             </a:solidFill>
             <a:prstDash val="solid"/>
           </a:ln>
-        </p:spPr>
-      </p:sp>
-      <p:sp>
-        <p:nvSpPr>
-          <p:cNvPr id="3" name="Text 1"/>
-          <p:cNvSpPr/>
-          <p:nvPr/>
-        </p:nvSpPr>
-        <p:spPr>
-          <a:xfrm>
-            <a:off x="731520" y="457200"/>
-            <a:ext cx="2231136" cy="310896"/>
+          <a:effectLst>
+            <a:outerShdw sx="100000" sy="100000" kx="0" ky="0" algn="bl" rotWithShape="0" blurRad="15240" dist="50800" dir="2700000">
+              <a:srgbClr val="7D8B98">
+                <a:alpha val="16000"/>
+              </a:srgbClr>
+            </a:outerShdw>
+          </a:effectLst>
+        </p:spPr>
+      </p:sp>
+      <p:sp>
+        <p:nvSpPr>
+          <p:cNvPr id="6" name="Text 3"/>
+          <p:cNvSpPr/>
+          <p:nvPr/>
+        </p:nvSpPr>
+        <p:spPr>
+          <a:xfrm>
+            <a:off x="8942832" y="1664208"/>
+            <a:ext cx="2231136" cy="566928"/>
           </a:xfrm>
           <a:prstGeom prst="rect">
             <a:avLst/>
@@ -11412,113 +12421,108 @@
               <a:buNone/>
             </a:pPr>
             <a:r>
-              <a:rPr lang="en-US" sz="1000" b="1" dirty="0">
-                <a:solidFill>
-                  <a:srgbClr val="FFFFFF"/>
-                </a:solidFill>
-                <a:latin typeface="Arial" pitchFamily="34" charset="0"/>
-                <a:ea typeface="Arial" pitchFamily="34" charset="-122"/>
-                <a:cs typeface="Arial" pitchFamily="34" charset="-120"/>
-              </a:rPr>
-              <a:t>CURRENT EVIDENCE VERDICT</a:t>
-            </a:r>
-            <a:endParaRPr lang="en-US" sz="1000" dirty="0"/>
-          </a:p>
-        </p:txBody>
-      </p:sp>
-      <p:sp>
-        <p:nvSpPr>
-          <p:cNvPr id="4" name="Text 2"/>
-          <p:cNvSpPr/>
-          <p:nvPr/>
-        </p:nvSpPr>
-        <p:spPr>
-          <a:xfrm>
-            <a:off x="713232" y="1078992"/>
-            <a:ext cx="6720840" cy="1170432"/>
-          </a:xfrm>
-          <a:prstGeom prst="rect">
-            <a:avLst/>
-          </a:prstGeom>
-          <a:noFill/>
-          <a:ln/>
-        </p:spPr>
-        <p:txBody>
-          <a:bodyPr wrap="square" lIns="0" tIns="0" rIns="0" bIns="0" rtlCol="0" anchor="t"/>
-          <a:lstStyle/>
-          <a:p>
-            <a:pPr algn="l" indent="0" marL="0">
-              <a:buNone/>
-            </a:pPr>
-            <a:r>
-              <a:rPr lang="en-US" sz="3600" b="1" dirty="0">
-                <a:solidFill>
-                  <a:srgbClr val="FFFFFF"/>
+              <a:rPr lang="en-US" sz="3300" b="1" dirty="0">
+                <a:solidFill>
+                  <a:srgbClr val="9B3B3B"/>
                 </a:solidFill>
                 <a:latin typeface="Cambria" pitchFamily="34" charset="0"/>
                 <a:ea typeface="Cambria" pitchFamily="34" charset="-122"/>
                 <a:cs typeface="Cambria" pitchFamily="34" charset="-120"/>
               </a:rPr>
-              <a:t>The measurement works.</a:t>
-            </a:r>
-            <a:endParaRPr lang="en-US" sz="3600" dirty="0"/>
-          </a:p>
-          <a:p>
-            <a:pPr algn="l" indent="0" marL="0">
-              <a:buNone/>
-            </a:pPr>
-            <a:r>
-              <a:rPr lang="en-US" sz="3600" b="1" dirty="0">
-                <a:solidFill>
-                  <a:srgbClr val="FFFFFF"/>
+              <a:t>154 / 157</a:t>
+            </a:r>
+            <a:endParaRPr lang="en-US" sz="3300" dirty="0"/>
+          </a:p>
+        </p:txBody>
+      </p:sp>
+      <p:sp>
+        <p:nvSpPr>
+          <p:cNvPr id="7" name="Text 4"/>
+          <p:cNvSpPr/>
+          <p:nvPr/>
+        </p:nvSpPr>
+        <p:spPr>
+          <a:xfrm>
+            <a:off x="8979408" y="2258568"/>
+            <a:ext cx="2157984" cy="329184"/>
+          </a:xfrm>
+          <a:prstGeom prst="rect">
+            <a:avLst/>
+          </a:prstGeom>
+          <a:noFill/>
+          <a:ln/>
+        </p:spPr>
+        <p:txBody>
+          <a:bodyPr wrap="square" lIns="0" tIns="0" rIns="0" bIns="0" rtlCol="0" anchor="ctr"/>
+          <a:lstStyle/>
+          <a:p>
+            <a:pPr algn="ctr" indent="0" marL="0">
+              <a:buNone/>
+            </a:pPr>
+            <a:r>
+              <a:rPr lang="en-US" sz="1250" dirty="0">
+                <a:solidFill>
+                  <a:srgbClr val="172431"/>
+                </a:solidFill>
+                <a:latin typeface="Arial" pitchFamily="34" charset="0"/>
+                <a:ea typeface="Arial" pitchFamily="34" charset="-122"/>
+                <a:cs typeface="Arial" pitchFamily="34" charset="-120"/>
+              </a:rPr>
+              <a:t>silent units marked by NCD</a:t>
+            </a:r>
+            <a:endParaRPr lang="en-US" sz="1250" dirty="0"/>
+          </a:p>
+        </p:txBody>
+      </p:sp>
+      <p:sp>
+        <p:nvSpPr>
+          <p:cNvPr id="8" name="Text 5"/>
+          <p:cNvSpPr/>
+          <p:nvPr/>
+        </p:nvSpPr>
+        <p:spPr>
+          <a:xfrm>
+            <a:off x="8979408" y="2907792"/>
+            <a:ext cx="2157984" cy="402336"/>
+          </a:xfrm>
+          <a:prstGeom prst="rect">
+            <a:avLst/>
+          </a:prstGeom>
+          <a:noFill/>
+          <a:ln/>
+        </p:spPr>
+        <p:txBody>
+          <a:bodyPr wrap="square" lIns="0" tIns="0" rIns="0" bIns="0" rtlCol="0" anchor="ctr"/>
+          <a:lstStyle/>
+          <a:p>
+            <a:pPr algn="ctr" indent="0" marL="0">
+              <a:buNone/>
+            </a:pPr>
+            <a:r>
+              <a:rPr lang="en-US" sz="2600" b="1" dirty="0">
+                <a:solidFill>
+                  <a:srgbClr val="7C3F68"/>
                 </a:solidFill>
                 <a:latin typeface="Cambria" pitchFamily="34" charset="0"/>
                 <a:ea typeface="Cambria" pitchFamily="34" charset="-122"/>
                 <a:cs typeface="Cambria" pitchFamily="34" charset="-120"/>
               </a:rPr>
-              <a:t>The innovation claim does not—yet.</a:t>
-            </a:r>
-            <a:endParaRPr lang="en-US" sz="3600" dirty="0"/>
-          </a:p>
-        </p:txBody>
-      </p:sp>
-      <p:sp>
-        <p:nvSpPr>
-          <p:cNvPr id="5" name="Shape 3"/>
-          <p:cNvSpPr/>
-          <p:nvPr/>
-        </p:nvSpPr>
-        <p:spPr>
-          <a:xfrm>
-            <a:off x="749808" y="2670048"/>
-            <a:ext cx="1170432" cy="310896"/>
-          </a:xfrm>
-          <a:prstGeom prst="roundRect">
-            <a:avLst>
-              <a:gd name="adj" fmla="val 23529"/>
-            </a:avLst>
-          </a:prstGeom>
-          <a:solidFill>
-            <a:srgbClr val="356B4D"/>
-          </a:solidFill>
-          <a:ln w="12700">
-            <a:solidFill>
-              <a:srgbClr val="356B4D"/>
-            </a:solidFill>
-            <a:prstDash val="solid"/>
-          </a:ln>
-        </p:spPr>
-      </p:sp>
-      <p:sp>
-        <p:nvSpPr>
-          <p:cNvPr id="6" name="Text 4"/>
-          <p:cNvSpPr/>
-          <p:nvPr/>
-        </p:nvSpPr>
-        <p:spPr>
-          <a:xfrm>
-            <a:off x="822960" y="2670048"/>
-            <a:ext cx="1024128" cy="310896"/>
+              <a:t>147 / 157</a:t>
+            </a:r>
+            <a:endParaRPr lang="en-US" sz="2600" dirty="0"/>
+          </a:p>
+        </p:txBody>
+      </p:sp>
+      <p:sp>
+        <p:nvSpPr>
+          <p:cNvPr id="9" name="Text 6"/>
+          <p:cNvSpPr/>
+          <p:nvPr/>
+        </p:nvSpPr>
+        <p:spPr>
+          <a:xfrm>
+            <a:off x="8979408" y="3346704"/>
+            <a:ext cx="2157984" cy="310896"/>
           </a:xfrm>
           <a:prstGeom prst="rect">
             <a:avLst/>
@@ -11534,69 +12538,108 @@
               <a:buNone/>
             </a:pPr>
             <a:r>
-              <a:rPr lang="en-US" sz="1000" b="1" dirty="0">
-                <a:solidFill>
-                  <a:srgbClr val="FFFFFF"/>
-                </a:solidFill>
-                <a:latin typeface="Arial" pitchFamily="34" charset="0"/>
-                <a:ea typeface="Arial" pitchFamily="34" charset="-122"/>
-                <a:cs typeface="Arial" pitchFamily="34" charset="-120"/>
-              </a:rPr>
-              <a:t>SUPPORTED</a:t>
-            </a:r>
-            <a:endParaRPr lang="en-US" sz="1000" dirty="0"/>
-          </a:p>
-        </p:txBody>
-      </p:sp>
-      <p:sp>
-        <p:nvSpPr>
-          <p:cNvPr id="7" name="Text 5"/>
-          <p:cNvSpPr/>
-          <p:nvPr/>
-        </p:nvSpPr>
-        <p:spPr>
-          <a:xfrm>
-            <a:off x="2121408" y="2642616"/>
-            <a:ext cx="6035040" cy="420624"/>
-          </a:xfrm>
-          <a:prstGeom prst="rect">
-            <a:avLst/>
-          </a:prstGeom>
-          <a:noFill/>
-          <a:ln/>
-        </p:spPr>
-        <p:txBody>
-          <a:bodyPr wrap="square" lIns="0" tIns="0" rIns="0" bIns="0" rtlCol="0" anchor="ctr"/>
-          <a:lstStyle/>
-          <a:p>
-            <a:pPr algn="l" indent="0" marL="0">
-              <a:buNone/>
-            </a:pPr>
-            <a:r>
-              <a:rPr lang="en-US" sz="1500" dirty="0">
-                <a:solidFill>
-                  <a:srgbClr val="FFFFFF"/>
-                </a:solidFill>
-                <a:latin typeface="Arial" pitchFamily="34" charset="0"/>
-                <a:ea typeface="Arial" pitchFamily="34" charset="-122"/>
-                <a:cs typeface="Arial" pitchFamily="34" charset="-120"/>
-              </a:rPr>
-              <a:t>Repeated explanations and intervention constructions are auditable.</a:t>
-            </a:r>
-            <a:endParaRPr lang="en-US" sz="1500" dirty="0"/>
-          </a:p>
-        </p:txBody>
-      </p:sp>
-      <p:sp>
-        <p:nvSpPr>
-          <p:cNvPr id="8" name="Shape 6"/>
-          <p:cNvSpPr/>
-          <p:nvPr/>
-        </p:nvSpPr>
-        <p:spPr>
-          <a:xfrm>
-            <a:off x="749808" y="3611880"/>
-            <a:ext cx="1170432" cy="310896"/>
+              <a:rPr lang="en-US" sz="1250" dirty="0">
+                <a:solidFill>
+                  <a:srgbClr val="172431"/>
+                </a:solidFill>
+                <a:latin typeface="Arial" pitchFamily="34" charset="0"/>
+                <a:ea typeface="Arial" pitchFamily="34" charset="-122"/>
+                <a:cs typeface="Arial" pitchFamily="34" charset="-120"/>
+              </a:rPr>
+              <a:t>still marked at q = 0.01</a:t>
+            </a:r>
+            <a:endParaRPr lang="en-US" sz="1250" dirty="0"/>
+          </a:p>
+        </p:txBody>
+      </p:sp>
+      <p:sp>
+        <p:nvSpPr>
+          <p:cNvPr id="10" name="Text 7"/>
+          <p:cNvSpPr/>
+          <p:nvPr/>
+        </p:nvSpPr>
+        <p:spPr>
+          <a:xfrm>
+            <a:off x="8979408" y="3950208"/>
+            <a:ext cx="2157984" cy="402336"/>
+          </a:xfrm>
+          <a:prstGeom prst="rect">
+            <a:avLst/>
+          </a:prstGeom>
+          <a:noFill/>
+          <a:ln/>
+        </p:spPr>
+        <p:txBody>
+          <a:bodyPr wrap="square" lIns="0" tIns="0" rIns="0" bIns="0" rtlCol="0" anchor="ctr"/>
+          <a:lstStyle/>
+          <a:p>
+            <a:pPr algn="ctr" indent="0" marL="0">
+              <a:buNone/>
+            </a:pPr>
+            <a:r>
+              <a:rPr lang="en-US" sz="2600" b="1" dirty="0">
+                <a:solidFill>
+                  <a:srgbClr val="B47B18"/>
+                </a:solidFill>
+                <a:latin typeface="Cambria" pitchFamily="34" charset="0"/>
+                <a:ea typeface="Cambria" pitchFamily="34" charset="-122"/>
+                <a:cs typeface="Cambria" pitchFamily="34" charset="-120"/>
+              </a:rPr>
+              <a:t>68 / 68</a:t>
+            </a:r>
+            <a:endParaRPr lang="en-US" sz="2600" dirty="0"/>
+          </a:p>
+        </p:txBody>
+      </p:sp>
+      <p:sp>
+        <p:nvSpPr>
+          <p:cNvPr id="11" name="Text 8"/>
+          <p:cNvSpPr/>
+          <p:nvPr/>
+        </p:nvSpPr>
+        <p:spPr>
+          <a:xfrm>
+            <a:off x="8979408" y="4407408"/>
+            <a:ext cx="2157984" cy="566928"/>
+          </a:xfrm>
+          <a:prstGeom prst="rect">
+            <a:avLst/>
+          </a:prstGeom>
+          <a:noFill/>
+          <a:ln/>
+        </p:spPr>
+        <p:txBody>
+          <a:bodyPr wrap="square" lIns="0" tIns="0" rIns="0" bIns="0" rtlCol="0" anchor="t"/>
+          <a:lstStyle/>
+          <a:p>
+            <a:pPr algn="ctr" indent="0" marL="0">
+              <a:buNone/>
+            </a:pPr>
+            <a:r>
+              <a:rPr lang="en-US" sz="1250" dirty="0">
+                <a:solidFill>
+                  <a:srgbClr val="172431"/>
+                </a:solidFill>
+                <a:latin typeface="Arial" pitchFamily="34" charset="0"/>
+                <a:ea typeface="Arial" pitchFamily="34" charset="-122"/>
+                <a:cs typeface="Arial" pitchFamily="34" charset="-120"/>
+              </a:rPr>
+              <a:t>future-observed units are positive; no comparison group</a:t>
+            </a:r>
+            <a:endParaRPr lang="en-US" sz="1250" dirty="0"/>
+          </a:p>
+        </p:txBody>
+      </p:sp>
+      <p:sp>
+        <p:nvSpPr>
+          <p:cNvPr id="12" name="Shape 9"/>
+          <p:cNvSpPr/>
+          <p:nvPr/>
+        </p:nvSpPr>
+        <p:spPr>
+          <a:xfrm>
+            <a:off x="8906256" y="5102352"/>
+            <a:ext cx="2304288" cy="310896"/>
           </a:xfrm>
           <a:prstGeom prst="roundRect">
             <a:avLst>
@@ -11616,14 +12659,14 @@
       </p:sp>
       <p:sp>
         <p:nvSpPr>
-          <p:cNvPr id="9" name="Text 7"/>
-          <p:cNvSpPr/>
-          <p:nvPr/>
-        </p:nvSpPr>
-        <p:spPr>
-          <a:xfrm>
-            <a:off x="822960" y="3611880"/>
-            <a:ext cx="1024128" cy="310896"/>
+          <p:cNvPr id="13" name="Text 10"/>
+          <p:cNvSpPr/>
+          <p:nvPr/>
+        </p:nvSpPr>
+        <p:spPr>
+          <a:xfrm>
+            <a:off x="8979408" y="5102352"/>
+            <a:ext cx="2157984" cy="310896"/>
           </a:xfrm>
           <a:prstGeom prst="rect">
             <a:avLst/>
@@ -11647,7 +12690,7 @@
                 <a:ea typeface="Arial" pitchFamily="34" charset="-122"/>
                 <a:cs typeface="Arial" pitchFamily="34" charset="-120"/>
               </a:rPr>
-              <a:t>NEGATIVE</a:t>
+              <a:t>NOT DETECTOR VALIDITY</a:t>
             </a:r>
             <a:endParaRPr lang="en-US" sz="1000" dirty="0"/>
           </a:p>
@@ -11655,65 +12698,26 @@
       </p:sp>
       <p:sp>
         <p:nvSpPr>
-          <p:cNvPr id="10" name="Text 8"/>
-          <p:cNvSpPr/>
-          <p:nvPr/>
-        </p:nvSpPr>
-        <p:spPr>
-          <a:xfrm>
-            <a:off x="2121408" y="3584448"/>
-            <a:ext cx="6035040" cy="420624"/>
-          </a:xfrm>
-          <a:prstGeom prst="rect">
-            <a:avLst/>
-          </a:prstGeom>
-          <a:noFill/>
-          <a:ln/>
-        </p:spPr>
-        <p:txBody>
-          <a:bodyPr wrap="square" lIns="0" tIns="0" rIns="0" bIns="0" rtlCol="0" anchor="ctr"/>
-          <a:lstStyle/>
-          <a:p>
-            <a:pPr algn="l" indent="0" marL="0">
-              <a:buNone/>
-            </a:pPr>
-            <a:r>
-              <a:rPr lang="en-US" sz="1500" dirty="0">
-                <a:solidFill>
-                  <a:srgbClr val="FFFFFF"/>
-                </a:solidFill>
-                <a:latin typeface="Arial" pitchFamily="34" charset="0"/>
-                <a:ea typeface="Arial" pitchFamily="34" charset="-122"/>
-                <a:cs typeface="Arial" pitchFamily="34" charset="-120"/>
-              </a:rPr>
-              <a:t>NCD ties B2 on eligible positives, adds one false positive, and saturates on the interim real-data slice.</a:t>
-            </a:r>
-            <a:endParaRPr lang="en-US" sz="1500" dirty="0"/>
-          </a:p>
-        </p:txBody>
-      </p:sp>
-      <p:sp>
-        <p:nvSpPr>
-          <p:cNvPr id="11" name="Shape 9"/>
-          <p:cNvSpPr/>
-          <p:nvPr/>
-        </p:nvSpPr>
-        <p:spPr>
-          <a:xfrm>
-            <a:off x="749808" y="4553712"/>
-            <a:ext cx="1170432" cy="310896"/>
+          <p:cNvPr id="14" name="Shape 11"/>
+          <p:cNvSpPr/>
+          <p:nvPr/>
+        </p:nvSpPr>
+        <p:spPr>
+          <a:xfrm>
+            <a:off x="1371600" y="5852160"/>
+            <a:ext cx="9473184" cy="475488"/>
           </a:xfrm>
           <a:prstGeom prst="roundRect">
             <a:avLst>
-              <a:gd name="adj" fmla="val 23529"/>
+              <a:gd name="adj" fmla="val 15385"/>
             </a:avLst>
           </a:prstGeom>
           <a:solidFill>
-            <a:srgbClr val="B47B18"/>
+            <a:srgbClr val="0B1F33"/>
           </a:solidFill>
           <a:ln w="12700">
             <a:solidFill>
-              <a:srgbClr val="B47B18"/>
+              <a:srgbClr val="0B1F33"/>
             </a:solidFill>
             <a:prstDash val="solid"/>
           </a:ln>
@@ -11721,14 +12725,14 @@
       </p:sp>
       <p:sp>
         <p:nvSpPr>
-          <p:cNvPr id="12" name="Text 10"/>
-          <p:cNvSpPr/>
-          <p:nvPr/>
-        </p:nvSpPr>
-        <p:spPr>
-          <a:xfrm>
-            <a:off x="822960" y="4553712"/>
-            <a:ext cx="1024128" cy="310896"/>
+          <p:cNvPr id="15" name="Text 12"/>
+          <p:cNvSpPr/>
+          <p:nvPr/>
+        </p:nvSpPr>
+        <p:spPr>
+          <a:xfrm>
+            <a:off x="1600200" y="5925312"/>
+            <a:ext cx="9015984" cy="274320"/>
           </a:xfrm>
           <a:prstGeom prst="rect">
             <a:avLst/>
@@ -11744,7 +12748,7 @@
               <a:buNone/>
             </a:pPr>
             <a:r>
-              <a:rPr lang="en-US" sz="1000" b="1" dirty="0">
+              <a:rPr lang="en-US" sz="1450" b="1" dirty="0">
                 <a:solidFill>
                   <a:srgbClr val="FFFFFF"/>
                 </a:solidFill>
@@ -11752,295 +12756,15 @@
                 <a:ea typeface="Arial" pitchFamily="34" charset="-122"/>
                 <a:cs typeface="Arial" pitchFamily="34" charset="-120"/>
               </a:rPr>
-              <a:t>OPEN</a:t>
-            </a:r>
-            <a:endParaRPr lang="en-US" sz="1000" dirty="0"/>
-          </a:p>
-        </p:txBody>
-      </p:sp>
-      <p:sp>
-        <p:nvSpPr>
-          <p:cNvPr id="13" name="Text 11"/>
-          <p:cNvSpPr/>
-          <p:nvPr/>
-        </p:nvSpPr>
-        <p:spPr>
-          <a:xfrm>
-            <a:off x="2121408" y="4526280"/>
-            <a:ext cx="6035040" cy="420624"/>
-          </a:xfrm>
-          <a:prstGeom prst="rect">
-            <a:avLst/>
-          </a:prstGeom>
-          <a:noFill/>
-          <a:ln/>
-        </p:spPr>
-        <p:txBody>
-          <a:bodyPr wrap="square" lIns="0" tIns="0" rIns="0" bIns="0" rtlCol="0" anchor="ctr"/>
-          <a:lstStyle/>
-          <a:p>
-            <a:pPr algn="l" indent="0" marL="0">
-              <a:buNone/>
-            </a:pPr>
-            <a:r>
-              <a:rPr lang="en-US" sz="1500" dirty="0">
-                <a:solidFill>
-                  <a:srgbClr val="FFFFFF"/>
-                </a:solidFill>
-                <a:latin typeface="Arial" pitchFamily="34" charset="0"/>
-                <a:ea typeface="Arial" pitchFamily="34" charset="-122"/>
-                <a:cs typeface="Arial" pitchFamily="34" charset="-120"/>
-              </a:rPr>
-              <a:t>Full 4-dataset × 7-method × 5-seed comparison, cross-explainer validity, future-recall relation, and RQ3 governance.</a:t>
-            </a:r>
-            <a:endParaRPr lang="en-US" sz="1500" dirty="0"/>
-          </a:p>
-        </p:txBody>
-      </p:sp>
-      <p:sp>
-        <p:nvSpPr>
-          <p:cNvPr id="14" name="Shape 12"/>
-          <p:cNvSpPr/>
-          <p:nvPr/>
-        </p:nvSpPr>
-        <p:spPr>
-          <a:xfrm>
-            <a:off x="8412480" y="1078992"/>
-            <a:ext cx="2926080" cy="4535424"/>
-          </a:xfrm>
-          <a:prstGeom prst="roundRect">
-            <a:avLst>
-              <a:gd name="adj" fmla="val 2500"/>
-            </a:avLst>
-          </a:prstGeom>
-          <a:solidFill>
-            <a:srgbClr val="132D45"/>
-          </a:solidFill>
-          <a:ln w="12700">
-            <a:solidFill>
-              <a:srgbClr val="26445D"/>
-            </a:solidFill>
-            <a:prstDash val="solid"/>
-          </a:ln>
-        </p:spPr>
-      </p:sp>
-      <p:sp>
-        <p:nvSpPr>
-          <p:cNvPr id="15" name="Text 13"/>
-          <p:cNvSpPr/>
-          <p:nvPr/>
-        </p:nvSpPr>
-        <p:spPr>
-          <a:xfrm>
-            <a:off x="8705088" y="1417320"/>
-            <a:ext cx="2331720" cy="402336"/>
-          </a:xfrm>
-          <a:prstGeom prst="rect">
-            <a:avLst/>
-          </a:prstGeom>
-          <a:noFill/>
-          <a:ln/>
-        </p:spPr>
-        <p:txBody>
-          <a:bodyPr wrap="square" lIns="0" tIns="0" rIns="0" bIns="0" rtlCol="0" anchor="ctr"/>
-          <a:lstStyle/>
-          <a:p>
-            <a:pPr algn="ctr" indent="0" marL="0">
-              <a:buNone/>
-            </a:pPr>
-            <a:r>
-              <a:rPr lang="en-US" sz="2100" b="1" dirty="0">
-                <a:solidFill>
-                  <a:srgbClr val="FFFFFF"/>
-                </a:solidFill>
-                <a:latin typeface="Cambria" pitchFamily="34" charset="0"/>
-                <a:ea typeface="Cambria" pitchFamily="34" charset="-122"/>
-                <a:cs typeface="Cambria" pitchFamily="34" charset="-120"/>
-              </a:rPr>
-              <a:t>HPC completion path</a:t>
-            </a:r>
-            <a:endParaRPr lang="en-US" sz="2100" dirty="0"/>
-          </a:p>
-        </p:txBody>
-      </p:sp>
-      <p:sp>
-        <p:nvSpPr>
-          <p:cNvPr id="16" name="Text 14"/>
-          <p:cNvSpPr/>
-          <p:nvPr/>
-        </p:nvSpPr>
-        <p:spPr>
-          <a:xfrm>
-            <a:off x="8723376" y="2029968"/>
-            <a:ext cx="2286000" cy="3090672"/>
-          </a:xfrm>
-          <a:prstGeom prst="rect">
-            <a:avLst/>
-          </a:prstGeom>
-          <a:noFill/>
-          <a:ln/>
-        </p:spPr>
-        <p:txBody>
-          <a:bodyPr wrap="square" lIns="0" tIns="0" rIns="0" bIns="0" rtlCol="0" anchor="t"/>
-          <a:lstStyle/>
-          <a:p>
-            <a:pPr algn="ctr" indent="0" marL="0">
-              <a:buNone/>
-            </a:pPr>
-            <a:r>
-              <a:rPr lang="en-US" sz="1400" dirty="0">
-                <a:solidFill>
-                  <a:srgbClr val="D7E2EB"/>
-                </a:solidFill>
-                <a:latin typeface="Arial" pitchFamily="34" charset="0"/>
-                <a:ea typeface="Arial" pitchFamily="34" charset="-122"/>
-                <a:cs typeface="Arial" pitchFamily="34" charset="-120"/>
-              </a:rPr>
-              <a:t>12 registered owned jobs</a:t>
-            </a:r>
-            <a:endParaRPr lang="en-US" sz="1400" dirty="0"/>
-          </a:p>
-          <a:p>
-            <a:pPr algn="ctr" indent="0" marL="0">
-              <a:buNone/>
-            </a:pPr>
-            <a:endParaRPr lang="en-US" sz="1400" dirty="0"/>
-          </a:p>
-          <a:p>
-            <a:pPr algn="ctr" indent="0" marL="0">
-              <a:buNone/>
-            </a:pPr>
-            <a:r>
-              <a:rPr lang="en-US" sz="1400" dirty="0">
-                <a:solidFill>
-                  <a:srgbClr val="D7E2EB"/>
-                </a:solidFill>
-                <a:latin typeface="Arial" pitchFamily="34" charset="0"/>
-                <a:ea typeface="Arial" pitchFamily="34" charset="-122"/>
-                <a:cs typeface="Arial" pitchFamily="34" charset="-120"/>
-              </a:rPr>
-              <a:t>4 primary training/explanation</a:t>
-            </a:r>
-            <a:endParaRPr lang="en-US" sz="1400" dirty="0"/>
-          </a:p>
-          <a:p>
-            <a:pPr algn="ctr" indent="0" marL="0">
-              <a:buNone/>
-            </a:pPr>
-            <a:r>
-              <a:rPr lang="en-US" sz="1400" dirty="0">
-                <a:solidFill>
-                  <a:srgbClr val="D7E2EB"/>
-                </a:solidFill>
-                <a:latin typeface="Arial" pitchFamily="34" charset="0"/>
-                <a:ea typeface="Arial" pitchFamily="34" charset="-122"/>
-                <a:cs typeface="Arial" pitchFamily="34" charset="-120"/>
-              </a:rPr>
-              <a:t>4 performance aggregation</a:t>
-            </a:r>
-            <a:endParaRPr lang="en-US" sz="1400" dirty="0"/>
-          </a:p>
-          <a:p>
-            <a:pPr algn="ctr" indent="0" marL="0">
-              <a:buNone/>
-            </a:pPr>
-            <a:r>
-              <a:rPr lang="en-US" sz="1400" dirty="0">
-                <a:solidFill>
-                  <a:srgbClr val="D7E2EB"/>
-                </a:solidFill>
-                <a:latin typeface="Arial" pitchFamily="34" charset="0"/>
-                <a:ea typeface="Arial" pitchFamily="34" charset="-122"/>
-                <a:cs typeface="Arial" pitchFamily="34" charset="-120"/>
-              </a:rPr>
-              <a:t>4 drift aggregation</a:t>
-            </a:r>
-            <a:endParaRPr lang="en-US" sz="1400" dirty="0"/>
-          </a:p>
-          <a:p>
-            <a:pPr algn="ctr" indent="0" marL="0">
-              <a:buNone/>
-            </a:pPr>
-            <a:endParaRPr lang="en-US" sz="1400" dirty="0"/>
-          </a:p>
-          <a:p>
-            <a:pPr algn="ctr" indent="0" marL="0">
-              <a:buNone/>
-            </a:pPr>
-            <a:r>
-              <a:rPr lang="en-US" sz="1400" dirty="0">
-                <a:solidFill>
-                  <a:srgbClr val="D7E2EB"/>
-                </a:solidFill>
-                <a:latin typeface="Arial" pitchFamily="34" charset="0"/>
-                <a:ea typeface="Arial" pitchFamily="34" charset="-122"/>
-                <a:cs typeface="Arial" pitchFamily="34" charset="-120"/>
-              </a:rPr>
-              <a:t>No duplicate submission.</a:t>
-            </a:r>
-            <a:endParaRPr lang="en-US" sz="1400" dirty="0"/>
-          </a:p>
-          <a:p>
-            <a:pPr algn="ctr" indent="0" marL="0">
-              <a:buNone/>
-            </a:pPr>
-            <a:r>
-              <a:rPr lang="en-US" sz="1400" dirty="0">
-                <a:solidFill>
-                  <a:srgbClr val="D7E2EB"/>
-                </a:solidFill>
-                <a:latin typeface="Arial" pitchFamily="34" charset="0"/>
-                <a:ea typeface="Arial" pitchFamily="34" charset="-122"/>
-                <a:cs typeface="Arial" pitchFamily="34" charset="-120"/>
-              </a:rPr>
-              <a:t>Final paper and deck update only after terminal, hash-verified evidence.</a:t>
-            </a:r>
-            <a:endParaRPr lang="en-US" sz="1400" dirty="0"/>
-          </a:p>
-        </p:txBody>
-      </p:sp>
-      <p:sp>
-        <p:nvSpPr>
-          <p:cNvPr id="17" name="Text 15"/>
-          <p:cNvSpPr/>
-          <p:nvPr/>
-        </p:nvSpPr>
-        <p:spPr>
-          <a:xfrm>
-            <a:off x="749808" y="5852160"/>
-            <a:ext cx="10405872" cy="438912"/>
-          </a:xfrm>
-          <a:prstGeom prst="rect">
-            <a:avLst/>
-          </a:prstGeom>
-          <a:noFill/>
-          <a:ln/>
-        </p:spPr>
-        <p:txBody>
-          <a:bodyPr wrap="square" lIns="0" tIns="0" rIns="0" bIns="0" rtlCol="0" anchor="ctr"/>
-          <a:lstStyle/>
-          <a:p>
-            <a:pPr algn="l" indent="0" marL="0">
-              <a:buNone/>
-            </a:pPr>
-            <a:r>
-              <a:rPr lang="en-US" sz="1500" b="1" dirty="0">
-                <a:solidFill>
-                  <a:srgbClr val="F0C8DE"/>
-                </a:solidFill>
-                <a:latin typeface="Arial" pitchFamily="34" charset="0"/>
-                <a:ea typeface="Arial" pitchFamily="34" charset="-122"/>
-                <a:cs typeface="Arial" pitchFamily="34" charset="-120"/>
-              </a:rPr>
-              <a:t>No current result establishes substantive innovation, cross-domain generality, or validated governance.</a:t>
-            </a:r>
-            <a:endParaRPr lang="en-US" sz="1500" dirty="0"/>
-          </a:p>
-        </p:txBody>
-      </p:sp>
-      <p:sp>
-        <p:nvSpPr>
-          <p:cNvPr id="18" name="Text 16"/>
+              <a:t>Finding: a completed larger slice confirms saturation; it does not establish prediction, causality, governance, or innovation.</a:t>
+            </a:r>
+            <a:endParaRPr lang="en-US" sz="1450" dirty="0"/>
+          </a:p>
+        </p:txBody>
+      </p:sp>
+      <p:sp>
+        <p:nvSpPr>
+          <p:cNvPr id="16" name="Text 13"/>
           <p:cNvSpPr/>
           <p:nvPr/>
         </p:nvSpPr>
@@ -12065,13 +12789,13 @@
             <a:r>
               <a:rPr lang="en-US" sz="850" dirty="0">
                 <a:solidFill>
-                  <a:srgbClr val="D5DEE7"/>
-                </a:solidFill>
-                <a:latin typeface="Arial" pitchFamily="34" charset="0"/>
-                <a:ea typeface="Arial" pitchFamily="34" charset="-122"/>
-                <a:cs typeface="Arial" pitchFamily="34" charset="-120"/>
-              </a:rPr>
-              <a:t>Next: replace interim tables only after all registered jobs complete and protected artifacts pass audit</a:t>
+                  <a:srgbClr val="5F6E7C"/>
+                </a:solidFill>
+                <a:latin typeface="Arial" pitchFamily="34" charset="0"/>
+                <a:ea typeface="Arial" pitchFamily="34" charset="-122"/>
+                <a:cs typeface="Arial" pitchFamily="34" charset="-120"/>
+              </a:rPr>
+              <a:t>Source: DICC jobs 483664 and 483686; protected 25-run NSL-KDD drift evidence</a:t>
             </a:r>
             <a:endParaRPr lang="en-US" sz="850" dirty="0"/>
           </a:p>
@@ -12079,7 +12803,7 @@
       </p:sp>
       <p:sp>
         <p:nvSpPr>
-          <p:cNvPr id="19" name="Text 17"/>
+          <p:cNvPr id="17" name="Text 14"/>
           <p:cNvSpPr/>
           <p:nvPr/>
         </p:nvSpPr>
@@ -12104,7 +12828,7 @@
             <a:r>
               <a:rPr lang="en-US" sz="900" dirty="0">
                 <a:solidFill>
-                  <a:srgbClr val="D5DEE7"/>
+                  <a:srgbClr val="5F6E7C"/>
                 </a:solidFill>
                 <a:latin typeface="Arial" pitchFamily="34" charset="0"/>
                 <a:ea typeface="Arial" pitchFamily="34" charset="-122"/>

</xml_diff>

<commit_message>
Report NSL cross-explainer saturation
</commit_message>
<xml_diff>
--- a/presentations/2026-10-10/NCD_Evidence_Update_2026-10-10.pptx
+++ b/presentations/2026-10-10/NCD_Evidence_Update_2026-10-10.pptx
@@ -12482,7 +12482,7 @@
         </p:nvSpPr>
         <p:spPr>
           <a:xfrm>
-            <a:off x="8979408" y="2907792"/>
+            <a:off x="8979408" y="2834640"/>
             <a:ext cx="2157984" cy="402336"/>
           </a:xfrm>
           <a:prstGeom prst="rect">
@@ -12501,13 +12501,13 @@
             <a:r>
               <a:rPr lang="en-US" sz="2600" b="1" dirty="0">
                 <a:solidFill>
-                  <a:srgbClr val="7C3F68"/>
+                  <a:srgbClr val="0C7C86"/>
                 </a:solidFill>
                 <a:latin typeface="Cambria" pitchFamily="34" charset="0"/>
                 <a:ea typeface="Cambria" pitchFamily="34" charset="-122"/>
                 <a:cs typeface="Cambria" pitchFamily="34" charset="-120"/>
               </a:rPr>
-              <a:t>147 / 157</a:t>
+              <a:t>91.72%</a:t>
             </a:r>
             <a:endParaRPr lang="en-US" sz="2600" dirty="0"/>
           </a:p>
@@ -12521,8 +12521,8 @@
         </p:nvSpPr>
         <p:spPr>
           <a:xfrm>
-            <a:off x="8979408" y="3346704"/>
-            <a:ext cx="2157984" cy="310896"/>
+            <a:off x="8979408" y="3255264"/>
+            <a:ext cx="2157984" cy="256032"/>
           </a:xfrm>
           <a:prstGeom prst="rect">
             <a:avLst/>
@@ -12538,7 +12538,7 @@
               <a:buNone/>
             </a:pPr>
             <a:r>
-              <a:rPr lang="en-US" sz="1250" dirty="0">
+              <a:rPr lang="en-US" sz="1200" dirty="0">
                 <a:solidFill>
                   <a:srgbClr val="172431"/>
                 </a:solidFill>
@@ -12546,9 +12546,9 @@
                 <a:ea typeface="Arial" pitchFamily="34" charset="-122"/>
                 <a:cs typeface="Arial" pitchFamily="34" charset="-120"/>
               </a:rPr>
-              <a:t>still marked at q = 0.01</a:t>
-            </a:r>
-            <a:endParaRPr lang="en-US" sz="1250" dirty="0"/>
+              <a:t>all-explainer agreement</a:t>
+            </a:r>
+            <a:endParaRPr lang="en-US" sz="1200" dirty="0"/>
           </a:p>
         </p:txBody>
       </p:sp>
@@ -12560,7 +12560,46 @@
         </p:nvSpPr>
         <p:spPr>
           <a:xfrm>
-            <a:off x="8979408" y="3950208"/>
+            <a:off x="8979408" y="3547872"/>
+            <a:ext cx="2157984" cy="256032"/>
+          </a:xfrm>
+          <a:prstGeom prst="rect">
+            <a:avLst/>
+          </a:prstGeom>
+          <a:noFill/>
+          <a:ln/>
+        </p:spPr>
+        <p:txBody>
+          <a:bodyPr wrap="square" lIns="0" tIns="0" rIns="0" bIns="0" rtlCol="0" anchor="ctr"/>
+          <a:lstStyle/>
+          <a:p>
+            <a:pPr algn="ctr" indent="0" marL="0">
+              <a:buNone/>
+            </a:pPr>
+            <a:r>
+              <a:rPr lang="en-US" sz="1150" b="1" dirty="0">
+                <a:solidFill>
+                  <a:srgbClr val="5F6E7C"/>
+                </a:solidFill>
+                <a:latin typeface="Arial" pitchFamily="34" charset="0"/>
+                <a:ea typeface="Arial" pitchFamily="34" charset="-122"/>
+                <a:cs typeface="Arial" pitchFamily="34" charset="-120"/>
+              </a:rPr>
+              <a:t>B1 70.70% · B2 69.43%</a:t>
+            </a:r>
+            <a:endParaRPr lang="en-US" sz="1150" dirty="0"/>
+          </a:p>
+        </p:txBody>
+      </p:sp>
+      <p:sp>
+        <p:nvSpPr>
+          <p:cNvPr id="11" name="Text 8"/>
+          <p:cNvSpPr/>
+          <p:nvPr/>
+        </p:nvSpPr>
+        <p:spPr>
+          <a:xfrm>
+            <a:off x="8979408" y="4041648"/>
             <a:ext cx="2157984" cy="402336"/>
           </a:xfrm>
           <a:prstGeom prst="rect">
@@ -12593,14 +12632,14 @@
       </p:sp>
       <p:sp>
         <p:nvSpPr>
-          <p:cNvPr id="11" name="Text 8"/>
-          <p:cNvSpPr/>
-          <p:nvPr/>
-        </p:nvSpPr>
-        <p:spPr>
-          <a:xfrm>
-            <a:off x="8979408" y="4407408"/>
-            <a:ext cx="2157984" cy="566928"/>
+          <p:cNvPr id="12" name="Text 9"/>
+          <p:cNvSpPr/>
+          <p:nvPr/>
+        </p:nvSpPr>
+        <p:spPr>
+          <a:xfrm>
+            <a:off x="8979408" y="4480560"/>
+            <a:ext cx="2157984" cy="512064"/>
           </a:xfrm>
           <a:prstGeom prst="rect">
             <a:avLst/>
@@ -12616,7 +12655,7 @@
               <a:buNone/>
             </a:pPr>
             <a:r>
-              <a:rPr lang="en-US" sz="1250" dirty="0">
+              <a:rPr lang="en-US" sz="1200" dirty="0">
                 <a:solidFill>
                   <a:srgbClr val="172431"/>
                 </a:solidFill>
@@ -12626,20 +12665,20 @@
               </a:rPr>
               <a:t>future-observed units are positive; no comparison group</a:t>
             </a:r>
-            <a:endParaRPr lang="en-US" sz="1250" dirty="0"/>
-          </a:p>
-        </p:txBody>
-      </p:sp>
-      <p:sp>
-        <p:nvSpPr>
-          <p:cNvPr id="12" name="Shape 9"/>
-          <p:cNvSpPr/>
-          <p:nvPr/>
-        </p:nvSpPr>
-        <p:spPr>
-          <a:xfrm>
-            <a:off x="8906256" y="5102352"/>
-            <a:ext cx="2304288" cy="310896"/>
+            <a:endParaRPr lang="en-US" sz="1200" dirty="0"/>
+          </a:p>
+        </p:txBody>
+      </p:sp>
+      <p:sp>
+        <p:nvSpPr>
+          <p:cNvPr id="13" name="Shape 10"/>
+          <p:cNvSpPr/>
+          <p:nvPr/>
+        </p:nvSpPr>
+        <p:spPr>
+          <a:xfrm>
+            <a:off x="8851392" y="5120640"/>
+            <a:ext cx="2414016" cy="310896"/>
           </a:xfrm>
           <a:prstGeom prst="roundRect">
             <a:avLst>
@@ -12659,14 +12698,14 @@
       </p:sp>
       <p:sp>
         <p:nvSpPr>
-          <p:cNvPr id="13" name="Text 10"/>
-          <p:cNvSpPr/>
-          <p:nvPr/>
-        </p:nvSpPr>
-        <p:spPr>
-          <a:xfrm>
-            <a:off x="8979408" y="5102352"/>
-            <a:ext cx="2157984" cy="310896"/>
+          <p:cNvPr id="14" name="Text 11"/>
+          <p:cNvSpPr/>
+          <p:nvPr/>
+        </p:nvSpPr>
+        <p:spPr>
+          <a:xfrm>
+            <a:off x="8924544" y="5120640"/>
+            <a:ext cx="2267712" cy="310896"/>
           </a:xfrm>
           <a:prstGeom prst="rect">
             <a:avLst/>
@@ -12690,7 +12729,7 @@
                 <a:ea typeface="Arial" pitchFamily="34" charset="-122"/>
                 <a:cs typeface="Arial" pitchFamily="34" charset="-120"/>
               </a:rPr>
-              <a:t>NOT DETECTOR VALIDITY</a:t>
+              <a:t>AGREEMENT VIA SATURATION</a:t>
             </a:r>
             <a:endParaRPr lang="en-US" sz="1000" dirty="0"/>
           </a:p>
@@ -12698,7 +12737,7 @@
       </p:sp>
       <p:sp>
         <p:nvSpPr>
-          <p:cNvPr id="14" name="Shape 11"/>
+          <p:cNvPr id="15" name="Shape 12"/>
           <p:cNvSpPr/>
           <p:nvPr/>
         </p:nvSpPr>
@@ -12725,7 +12764,7 @@
       </p:sp>
       <p:sp>
         <p:nvSpPr>
-          <p:cNvPr id="15" name="Text 12"/>
+          <p:cNvPr id="16" name="Text 13"/>
           <p:cNvSpPr/>
           <p:nvPr/>
         </p:nvSpPr>
@@ -12764,7 +12803,7 @@
       </p:sp>
       <p:sp>
         <p:nvSpPr>
-          <p:cNvPr id="16" name="Text 13"/>
+          <p:cNvPr id="17" name="Text 14"/>
           <p:cNvSpPr/>
           <p:nvPr/>
         </p:nvSpPr>
@@ -12803,7 +12842,7 @@
       </p:sp>
       <p:sp>
         <p:nvSpPr>
-          <p:cNvPr id="17" name="Text 14"/>
+          <p:cNvPr id="18" name="Text 15"/>
           <p:cNvSpPr/>
           <p:nvPr/>
         </p:nvSpPr>

</xml_diff>